<commit_message>
final commit before jasper rust api implementation
</commit_message>
<xml_diff>
--- a/HTC-End-to-End-Visibility-Monitoring (1).pptx
+++ b/HTC-End-to-End-Visibility-Monitoring (1).pptx
@@ -1462,9 +1462,322 @@
           <a:chExt cx="0" cy="0"/>
         </a:xfrm>
       </p:grpSpPr>
+      <p:sp>
+        <p:nvSpPr>
+          <p:cNvPr id="3" name="Text 0"/>
+          <p:cNvSpPr/>
+          <p:nvPr/>
+        </p:nvSpPr>
+        <p:spPr>
+          <a:xfrm>
+            <a:off x="496119" y="1494830"/>
+            <a:ext cx="5011383" cy="885974"/>
+          </a:xfrm>
+          <a:prstGeom prst="rect">
+            <a:avLst/>
+          </a:prstGeom>
+          <a:noFill/>
+          <a:ln/>
+        </p:spPr>
+        <p:txBody>
+          <a:bodyPr wrap="square" lIns="0" tIns="0" rIns="0" bIns="0" rtlCol="0" anchor="t">
+            <a:normAutofit/>
+          </a:bodyPr>
+          <a:lstStyle/>
+          <a:p>
+            <a:pPr marL="0" indent="0" algn="l">
+              <a:lnSpc>
+                <a:spcPct val="104000"/>
+              </a:lnSpc>
+              <a:buNone/>
+            </a:pPr>
+            <a:r>
+              <a:rPr lang="en-US" sz="2750" dirty="0">
+                <a:solidFill>
+                  <a:srgbClr val="000000"/>
+                </a:solidFill>
+                <a:latin typeface="DM Sans SemiBold" pitchFamily="34" charset="0"/>
+                <a:ea typeface="DM Sans SemiBold" pitchFamily="34" charset="-122"/>
+                <a:cs typeface="DM Sans SemiBold" pitchFamily="34" charset="-120"/>
+              </a:rPr>
+              <a:t>HTC End-to-End Visibility Monitoring</a:t>
+            </a:r>
+            <a:endParaRPr lang="en-US" sz="2750" dirty="0"/>
+          </a:p>
+        </p:txBody>
+      </p:sp>
+      <p:sp>
+        <p:nvSpPr>
+          <p:cNvPr id="4" name="Text 1"/>
+          <p:cNvSpPr/>
+          <p:nvPr/>
+        </p:nvSpPr>
+        <p:spPr>
+          <a:xfrm>
+            <a:off x="496119" y="2593404"/>
+            <a:ext cx="4722763" cy="680442"/>
+          </a:xfrm>
+          <a:prstGeom prst="rect">
+            <a:avLst/>
+          </a:prstGeom>
+          <a:noFill/>
+          <a:ln/>
+        </p:spPr>
+        <p:txBody>
+          <a:bodyPr wrap="square" lIns="0" tIns="0" rIns="0" bIns="0" rtlCol="0" anchor="t">
+            <a:normAutofit/>
+          </a:bodyPr>
+          <a:lstStyle/>
+          <a:p>
+            <a:pPr marL="0" indent="0" algn="l">
+              <a:lnSpc>
+                <a:spcPct val="133000"/>
+              </a:lnSpc>
+              <a:buNone/>
+            </a:pPr>
+            <a:r>
+              <a:rPr lang="en-US" sz="1100" dirty="0">
+                <a:solidFill>
+                  <a:srgbClr val="464646"/>
+                </a:solidFill>
+                <a:latin typeface="Inter Medium" pitchFamily="34" charset="0"/>
+                <a:ea typeface="Inter Medium" pitchFamily="34" charset="-122"/>
+                <a:cs typeface="Inter Medium" pitchFamily="34" charset="-120"/>
+              </a:rPr>
+              <a:t>Extension of the Hard Time Configuration Slot Visibility Monitoring framework — adding automated alerts for part movement and serial number integrity.</a:t>
+            </a:r>
+            <a:endParaRPr lang="en-US" sz="1100" dirty="0"/>
+          </a:p>
+        </p:txBody>
+      </p:sp>
+      <p:sp>
+        <p:nvSpPr>
+          <p:cNvPr id="5" name="Shape 2"/>
+          <p:cNvSpPr/>
+          <p:nvPr/>
+        </p:nvSpPr>
+        <p:spPr>
+          <a:xfrm>
+            <a:off x="496119" y="3433316"/>
+            <a:ext cx="1333723" cy="215354"/>
+          </a:xfrm>
+          <a:prstGeom prst="roundRect">
+            <a:avLst>
+              <a:gd name="adj" fmla="val 22119"/>
+            </a:avLst>
+          </a:prstGeom>
+          <a:solidFill>
+            <a:srgbClr val="D0E2FB"/>
+          </a:solidFill>
+          <a:ln/>
+        </p:spPr>
+        <p:txBody>
+          <a:bodyPr/>
+          <a:lstStyle/>
+          <a:p>
+            <a:endParaRPr lang="en-GB"/>
+          </a:p>
+        </p:txBody>
+      </p:sp>
+      <p:sp>
+        <p:nvSpPr>
+          <p:cNvPr id="6" name="Text 3"/>
+          <p:cNvSpPr/>
+          <p:nvPr/>
+        </p:nvSpPr>
+        <p:spPr>
+          <a:xfrm>
+            <a:off x="581174" y="3475806"/>
+            <a:ext cx="1620813" cy="130373"/>
+          </a:xfrm>
+          <a:prstGeom prst="rect">
+            <a:avLst/>
+          </a:prstGeom>
+          <a:noFill/>
+          <a:ln/>
+        </p:spPr>
+        <p:txBody>
+          <a:bodyPr wrap="none" lIns="0" tIns="0" rIns="0" bIns="0" rtlCol="0" anchor="t"/>
+          <a:lstStyle/>
+          <a:p>
+            <a:pPr marL="0" indent="0" algn="l">
+              <a:lnSpc>
+                <a:spcPct val="96000"/>
+              </a:lnSpc>
+              <a:buNone/>
+            </a:pPr>
+            <a:r>
+              <a:rPr lang="en-US" sz="850" dirty="0">
+                <a:solidFill>
+                  <a:srgbClr val="464646"/>
+                </a:solidFill>
+                <a:latin typeface="Inter Medium" pitchFamily="34" charset="0"/>
+                <a:ea typeface="Inter Medium" pitchFamily="34" charset="-122"/>
+                <a:cs typeface="Inter Medium" pitchFamily="34" charset="-120"/>
+              </a:rPr>
+              <a:t>PROJECT PROPOSAL</a:t>
+            </a:r>
+            <a:endParaRPr lang="en-US" sz="850" dirty="0"/>
+          </a:p>
+        </p:txBody>
+      </p:sp>
+      <p:sp>
+        <p:nvSpPr>
+          <p:cNvPr id="7" name="Shape 4"/>
+          <p:cNvSpPr/>
+          <p:nvPr/>
+        </p:nvSpPr>
+        <p:spPr>
+          <a:xfrm>
+            <a:off x="1900684" y="3433316"/>
+            <a:ext cx="787747" cy="215354"/>
+          </a:xfrm>
+          <a:prstGeom prst="roundRect">
+            <a:avLst>
+              <a:gd name="adj" fmla="val 22119"/>
+            </a:avLst>
+          </a:prstGeom>
+          <a:noFill/>
+          <a:ln w="4763">
+            <a:solidFill>
+              <a:srgbClr val="1370EC"/>
+            </a:solidFill>
+            <a:prstDash val="solid"/>
+          </a:ln>
+        </p:spPr>
+        <p:txBody>
+          <a:bodyPr/>
+          <a:lstStyle/>
+          <a:p>
+            <a:endParaRPr lang="en-GB"/>
+          </a:p>
+        </p:txBody>
+      </p:sp>
+      <p:sp>
+        <p:nvSpPr>
+          <p:cNvPr id="8" name="Text 5"/>
+          <p:cNvSpPr/>
+          <p:nvPr/>
+        </p:nvSpPr>
+        <p:spPr>
+          <a:xfrm>
+            <a:off x="1985739" y="3475806"/>
+            <a:ext cx="1074837" cy="130373"/>
+          </a:xfrm>
+          <a:prstGeom prst="rect">
+            <a:avLst/>
+          </a:prstGeom>
+          <a:noFill/>
+          <a:ln/>
+        </p:spPr>
+        <p:txBody>
+          <a:bodyPr wrap="none" lIns="0" tIns="0" rIns="0" bIns="0" rtlCol="0" anchor="t"/>
+          <a:lstStyle/>
+          <a:p>
+            <a:pPr marL="0" indent="0" algn="l">
+              <a:lnSpc>
+                <a:spcPct val="96000"/>
+              </a:lnSpc>
+              <a:buNone/>
+            </a:pPr>
+            <a:r>
+              <a:rPr lang="en-US" sz="850" dirty="0">
+                <a:solidFill>
+                  <a:srgbClr val="1370EC"/>
+                </a:solidFill>
+                <a:latin typeface="Inter Medium" pitchFamily="34" charset="0"/>
+                <a:ea typeface="Inter Medium" pitchFamily="34" charset="-122"/>
+                <a:cs typeface="Inter Medium" pitchFamily="34" charset="-120"/>
+              </a:rPr>
+              <a:t>JUNE 2026</a:t>
+            </a:r>
+            <a:endParaRPr lang="en-US" sz="850" dirty="0"/>
+          </a:p>
+        </p:txBody>
+      </p:sp>
+      <p:sp>
+        <p:nvSpPr>
+          <p:cNvPr id="9" name="Shape 6"/>
+          <p:cNvSpPr/>
+          <p:nvPr/>
+        </p:nvSpPr>
+        <p:spPr>
+          <a:xfrm>
+            <a:off x="2759273" y="3433316"/>
+            <a:ext cx="850702" cy="215354"/>
+          </a:xfrm>
+          <a:prstGeom prst="roundRect">
+            <a:avLst>
+              <a:gd name="adj" fmla="val 22119"/>
+            </a:avLst>
+          </a:prstGeom>
+          <a:noFill/>
+          <a:ln w="4763">
+            <a:solidFill>
+              <a:srgbClr val="1370EC"/>
+            </a:solidFill>
+            <a:prstDash val="solid"/>
+          </a:ln>
+        </p:spPr>
+        <p:txBody>
+          <a:bodyPr/>
+          <a:lstStyle/>
+          <a:p>
+            <a:endParaRPr lang="en-GB"/>
+          </a:p>
+        </p:txBody>
+      </p:sp>
+      <p:sp>
+        <p:nvSpPr>
+          <p:cNvPr id="10" name="Text 7"/>
+          <p:cNvSpPr/>
+          <p:nvPr/>
+        </p:nvSpPr>
+        <p:spPr>
+          <a:xfrm>
+            <a:off x="2844329" y="3475806"/>
+            <a:ext cx="1137791" cy="130373"/>
+          </a:xfrm>
+          <a:prstGeom prst="rect">
+            <a:avLst/>
+          </a:prstGeom>
+          <a:noFill/>
+          <a:ln/>
+        </p:spPr>
+        <p:txBody>
+          <a:bodyPr wrap="none" lIns="0" tIns="0" rIns="0" bIns="0" rtlCol="0" anchor="t"/>
+          <a:lstStyle/>
+          <a:p>
+            <a:pPr marL="0" indent="0" algn="l">
+              <a:lnSpc>
+                <a:spcPct val="96000"/>
+              </a:lnSpc>
+              <a:buNone/>
+            </a:pPr>
+            <a:r>
+              <a:rPr lang="en-US" sz="850" dirty="0">
+                <a:solidFill>
+                  <a:srgbClr val="1370EC"/>
+                </a:solidFill>
+                <a:latin typeface="Inter Medium" pitchFamily="34" charset="0"/>
+                <a:ea typeface="Inter Medium" pitchFamily="34" charset="-122"/>
+                <a:cs typeface="Inter Medium" pitchFamily="34" charset="-120"/>
+              </a:rPr>
+              <a:t>VERSION 1.0</a:t>
+            </a:r>
+            <a:endParaRPr lang="en-US" sz="850" dirty="0"/>
+          </a:p>
+        </p:txBody>
+      </p:sp>
       <p:pic>
         <p:nvPicPr>
-          <p:cNvPr id="2" name="Image 0" descr="preencoded.png"/>
+          <p:cNvPr id="12" name="Picture 11">
+            <a:extLst>
+              <a:ext uri="{FF2B5EF4-FFF2-40B4-BE49-F238E27FC236}">
+                <a16:creationId xmlns:a16="http://schemas.microsoft.com/office/drawing/2014/main" id="{CDE85DB4-4675-EC67-7D2D-54A6D3137DC4}"/>
+              </a:ext>
+            </a:extLst>
+          </p:cNvPr>
           <p:cNvPicPr>
             <a:picLocks noChangeAspect="1"/>
           </p:cNvPicPr>
@@ -1478,321 +1791,14 @@
         </p:blipFill>
         <p:spPr>
           <a:xfrm>
-            <a:off x="5715000" y="0"/>
-            <a:ext cx="3429000" cy="5143500"/>
+            <a:off x="5592971" y="21654"/>
+            <a:ext cx="3551029" cy="5143500"/>
           </a:xfrm>
           <a:prstGeom prst="rect">
             <a:avLst/>
           </a:prstGeom>
         </p:spPr>
       </p:pic>
-      <p:sp>
-        <p:nvSpPr>
-          <p:cNvPr id="3" name="Text 0"/>
-          <p:cNvSpPr/>
-          <p:nvPr/>
-        </p:nvSpPr>
-        <p:spPr>
-          <a:xfrm>
-            <a:off x="496119" y="1494830"/>
-            <a:ext cx="5011383" cy="885974"/>
-          </a:xfrm>
-          <a:prstGeom prst="rect">
-            <a:avLst/>
-          </a:prstGeom>
-          <a:noFill/>
-          <a:ln/>
-        </p:spPr>
-        <p:txBody>
-          <a:bodyPr wrap="square" lIns="0" tIns="0" rIns="0" bIns="0" rtlCol="0" anchor="t">
-            <a:normAutofit/>
-          </a:bodyPr>
-          <a:lstStyle/>
-          <a:p>
-            <a:pPr marL="0" indent="0" algn="l">
-              <a:lnSpc>
-                <a:spcPct val="104000"/>
-              </a:lnSpc>
-              <a:buNone/>
-            </a:pPr>
-            <a:r>
-              <a:rPr lang="en-US" sz="2750" dirty="0">
-                <a:solidFill>
-                  <a:srgbClr val="000000"/>
-                </a:solidFill>
-                <a:latin typeface="DM Sans SemiBold" pitchFamily="34" charset="0"/>
-                <a:ea typeface="DM Sans SemiBold" pitchFamily="34" charset="-122"/>
-                <a:cs typeface="DM Sans SemiBold" pitchFamily="34" charset="-120"/>
-              </a:rPr>
-              <a:t>HTC End-to-End Visibility Monitoring</a:t>
-            </a:r>
-            <a:endParaRPr lang="en-US" sz="2750" dirty="0"/>
-          </a:p>
-        </p:txBody>
-      </p:sp>
-      <p:sp>
-        <p:nvSpPr>
-          <p:cNvPr id="4" name="Text 1"/>
-          <p:cNvSpPr/>
-          <p:nvPr/>
-        </p:nvSpPr>
-        <p:spPr>
-          <a:xfrm>
-            <a:off x="496119" y="2593404"/>
-            <a:ext cx="4722763" cy="680442"/>
-          </a:xfrm>
-          <a:prstGeom prst="rect">
-            <a:avLst/>
-          </a:prstGeom>
-          <a:noFill/>
-          <a:ln/>
-        </p:spPr>
-        <p:txBody>
-          <a:bodyPr wrap="square" lIns="0" tIns="0" rIns="0" bIns="0" rtlCol="0" anchor="t">
-            <a:normAutofit/>
-          </a:bodyPr>
-          <a:lstStyle/>
-          <a:p>
-            <a:pPr marL="0" indent="0" algn="l">
-              <a:lnSpc>
-                <a:spcPct val="133000"/>
-              </a:lnSpc>
-              <a:buNone/>
-            </a:pPr>
-            <a:r>
-              <a:rPr lang="en-US" sz="1100" dirty="0">
-                <a:solidFill>
-                  <a:srgbClr val="464646"/>
-                </a:solidFill>
-                <a:latin typeface="Inter Medium" pitchFamily="34" charset="0"/>
-                <a:ea typeface="Inter Medium" pitchFamily="34" charset="-122"/>
-                <a:cs typeface="Inter Medium" pitchFamily="34" charset="-120"/>
-              </a:rPr>
-              <a:t>Extension of the Hard Time Configuration Slot Visibility Monitoring framework — adding automated alerts for part movement and serial number integrity.</a:t>
-            </a:r>
-            <a:endParaRPr lang="en-US" sz="1100" dirty="0"/>
-          </a:p>
-        </p:txBody>
-      </p:sp>
-      <p:sp>
-        <p:nvSpPr>
-          <p:cNvPr id="5" name="Shape 2"/>
-          <p:cNvSpPr/>
-          <p:nvPr/>
-        </p:nvSpPr>
-        <p:spPr>
-          <a:xfrm>
-            <a:off x="496119" y="3433316"/>
-            <a:ext cx="1333723" cy="215354"/>
-          </a:xfrm>
-          <a:prstGeom prst="roundRect">
-            <a:avLst>
-              <a:gd name="adj" fmla="val 22119"/>
-            </a:avLst>
-          </a:prstGeom>
-          <a:solidFill>
-            <a:srgbClr val="D0E2FB"/>
-          </a:solidFill>
-          <a:ln/>
-        </p:spPr>
-        <p:txBody>
-          <a:bodyPr/>
-          <a:lstStyle/>
-          <a:p>
-            <a:endParaRPr lang="en-GB"/>
-          </a:p>
-        </p:txBody>
-      </p:sp>
-      <p:sp>
-        <p:nvSpPr>
-          <p:cNvPr id="6" name="Text 3"/>
-          <p:cNvSpPr/>
-          <p:nvPr/>
-        </p:nvSpPr>
-        <p:spPr>
-          <a:xfrm>
-            <a:off x="581174" y="3475806"/>
-            <a:ext cx="1620813" cy="130373"/>
-          </a:xfrm>
-          <a:prstGeom prst="rect">
-            <a:avLst/>
-          </a:prstGeom>
-          <a:noFill/>
-          <a:ln/>
-        </p:spPr>
-        <p:txBody>
-          <a:bodyPr wrap="none" lIns="0" tIns="0" rIns="0" bIns="0" rtlCol="0" anchor="t"/>
-          <a:lstStyle/>
-          <a:p>
-            <a:pPr marL="0" indent="0" algn="l">
-              <a:lnSpc>
-                <a:spcPct val="96000"/>
-              </a:lnSpc>
-              <a:buNone/>
-            </a:pPr>
-            <a:r>
-              <a:rPr lang="en-US" sz="850" dirty="0">
-                <a:solidFill>
-                  <a:srgbClr val="464646"/>
-                </a:solidFill>
-                <a:latin typeface="Inter Medium" pitchFamily="34" charset="0"/>
-                <a:ea typeface="Inter Medium" pitchFamily="34" charset="-122"/>
-                <a:cs typeface="Inter Medium" pitchFamily="34" charset="-120"/>
-              </a:rPr>
-              <a:t>PROJECT PROPOSAL</a:t>
-            </a:r>
-            <a:endParaRPr lang="en-US" sz="850" dirty="0"/>
-          </a:p>
-        </p:txBody>
-      </p:sp>
-      <p:sp>
-        <p:nvSpPr>
-          <p:cNvPr id="7" name="Shape 4"/>
-          <p:cNvSpPr/>
-          <p:nvPr/>
-        </p:nvSpPr>
-        <p:spPr>
-          <a:xfrm>
-            <a:off x="1900684" y="3433316"/>
-            <a:ext cx="787747" cy="215354"/>
-          </a:xfrm>
-          <a:prstGeom prst="roundRect">
-            <a:avLst>
-              <a:gd name="adj" fmla="val 22119"/>
-            </a:avLst>
-          </a:prstGeom>
-          <a:noFill/>
-          <a:ln w="4763">
-            <a:solidFill>
-              <a:srgbClr val="1370EC"/>
-            </a:solidFill>
-            <a:prstDash val="solid"/>
-          </a:ln>
-        </p:spPr>
-        <p:txBody>
-          <a:bodyPr/>
-          <a:lstStyle/>
-          <a:p>
-            <a:endParaRPr lang="en-GB"/>
-          </a:p>
-        </p:txBody>
-      </p:sp>
-      <p:sp>
-        <p:nvSpPr>
-          <p:cNvPr id="8" name="Text 5"/>
-          <p:cNvSpPr/>
-          <p:nvPr/>
-        </p:nvSpPr>
-        <p:spPr>
-          <a:xfrm>
-            <a:off x="1985739" y="3475806"/>
-            <a:ext cx="1074837" cy="130373"/>
-          </a:xfrm>
-          <a:prstGeom prst="rect">
-            <a:avLst/>
-          </a:prstGeom>
-          <a:noFill/>
-          <a:ln/>
-        </p:spPr>
-        <p:txBody>
-          <a:bodyPr wrap="none" lIns="0" tIns="0" rIns="0" bIns="0" rtlCol="0" anchor="t"/>
-          <a:lstStyle/>
-          <a:p>
-            <a:pPr marL="0" indent="0" algn="l">
-              <a:lnSpc>
-                <a:spcPct val="96000"/>
-              </a:lnSpc>
-              <a:buNone/>
-            </a:pPr>
-            <a:r>
-              <a:rPr lang="en-US" sz="850" dirty="0">
-                <a:solidFill>
-                  <a:srgbClr val="1370EC"/>
-                </a:solidFill>
-                <a:latin typeface="Inter Medium" pitchFamily="34" charset="0"/>
-                <a:ea typeface="Inter Medium" pitchFamily="34" charset="-122"/>
-                <a:cs typeface="Inter Medium" pitchFamily="34" charset="-120"/>
-              </a:rPr>
-              <a:t>JUNE 2026</a:t>
-            </a:r>
-            <a:endParaRPr lang="en-US" sz="850" dirty="0"/>
-          </a:p>
-        </p:txBody>
-      </p:sp>
-      <p:sp>
-        <p:nvSpPr>
-          <p:cNvPr id="9" name="Shape 6"/>
-          <p:cNvSpPr/>
-          <p:nvPr/>
-        </p:nvSpPr>
-        <p:spPr>
-          <a:xfrm>
-            <a:off x="2759273" y="3433316"/>
-            <a:ext cx="850702" cy="215354"/>
-          </a:xfrm>
-          <a:prstGeom prst="roundRect">
-            <a:avLst>
-              <a:gd name="adj" fmla="val 22119"/>
-            </a:avLst>
-          </a:prstGeom>
-          <a:noFill/>
-          <a:ln w="4763">
-            <a:solidFill>
-              <a:srgbClr val="1370EC"/>
-            </a:solidFill>
-            <a:prstDash val="solid"/>
-          </a:ln>
-        </p:spPr>
-        <p:txBody>
-          <a:bodyPr/>
-          <a:lstStyle/>
-          <a:p>
-            <a:endParaRPr lang="en-GB"/>
-          </a:p>
-        </p:txBody>
-      </p:sp>
-      <p:sp>
-        <p:nvSpPr>
-          <p:cNvPr id="10" name="Text 7"/>
-          <p:cNvSpPr/>
-          <p:nvPr/>
-        </p:nvSpPr>
-        <p:spPr>
-          <a:xfrm>
-            <a:off x="2844329" y="3475806"/>
-            <a:ext cx="1137791" cy="130373"/>
-          </a:xfrm>
-          <a:prstGeom prst="rect">
-            <a:avLst/>
-          </a:prstGeom>
-          <a:noFill/>
-          <a:ln/>
-        </p:spPr>
-        <p:txBody>
-          <a:bodyPr wrap="none" lIns="0" tIns="0" rIns="0" bIns="0" rtlCol="0" anchor="t"/>
-          <a:lstStyle/>
-          <a:p>
-            <a:pPr marL="0" indent="0" algn="l">
-              <a:lnSpc>
-                <a:spcPct val="96000"/>
-              </a:lnSpc>
-              <a:buNone/>
-            </a:pPr>
-            <a:r>
-              <a:rPr lang="en-US" sz="850" dirty="0">
-                <a:solidFill>
-                  <a:srgbClr val="1370EC"/>
-                </a:solidFill>
-                <a:latin typeface="Inter Medium" pitchFamily="34" charset="0"/>
-                <a:ea typeface="Inter Medium" pitchFamily="34" charset="-122"/>
-                <a:cs typeface="Inter Medium" pitchFamily="34" charset="-120"/>
-              </a:rPr>
-              <a:t>VERSION 1.0</a:t>
-            </a:r>
-            <a:endParaRPr lang="en-US" sz="850" dirty="0"/>
-          </a:p>
-        </p:txBody>
-      </p:sp>
     </p:spTree>
   </p:cSld>
   <p:clrMapOvr>

</xml_diff>